<commit_message>
Point the pitch deck at the PromptShield repository.
Co-authored-by: Cursor <cursoragent@cursor.com>
</commit_message>
<xml_diff>
--- a/docs/pitch/PromptShield_pitch.pptx
+++ b/docs/pitch/PromptShield_pitch.pptx
@@ -3489,7 +3489,7 @@
                 </a:solidFill>
                 <a:latin typeface="Arial"/>
               </a:rPr>
-              <a:t>https://github.com/Sohamsurve/PrmoptShield</a:t>
+              <a:t>https://github.com/Sohamsurve/PromptShield</a:t>
             </a:r>
           </a:p>
         </p:txBody>
@@ -11020,7 +11020,7 @@
                 </a:solidFill>
                 <a:latin typeface="Arial"/>
               </a:rPr>
-              <a:t>https://github.com/Sohamsurve/PrmoptShield</a:t>
+              <a:t>https://github.com/Sohamsurve/PromptShield</a:t>
             </a:r>
           </a:p>
         </p:txBody>

</xml_diff>

<commit_message>
Update README and pitch materials for ET AI Hackathon submission. The README now highlights the product, provisional F1/D1 declaration, golden-suite results, and demo instructions. Added submitter information and updated links in the pitch deck. Removed outdated demo script files.
</commit_message>
<xml_diff>
--- a/docs/pitch/PromptShield_pitch.pptx
+++ b/docs/pitch/PromptShield_pitch.pptx
@@ -3489,7 +3489,40 @@
                 </a:solidFill>
                 <a:latin typeface="Arial"/>
               </a:rPr>
-              <a:t>https://github.com/Sohamsurve/PromptShield</a:t>
+              <a:t>https://github.com/Sohamsurve/PromptShield.git</a:t>
+            </a:r>
+          </a:p>
+        </p:txBody>
+      </p:sp>
+      <p:sp>
+        <p:nvSpPr>
+          <p:cNvPr id="13" name="TextBox 12"/>
+          <p:cNvSpPr txBox="1"/>
+          <p:nvPr/>
+        </p:nvSpPr>
+        <p:spPr>
+          <a:xfrm>
+            <a:off x="502920" y="5257800"/>
+            <a:ext cx="9144000" cy="365760"/>
+          </a:xfrm>
+          <a:prstGeom prst="rect">
+            <a:avLst/>
+          </a:prstGeom>
+          <a:noFill/>
+        </p:spPr>
+        <p:txBody>
+          <a:bodyPr wrap="square" anchor="t"/>
+          <a:lstStyle/>
+          <a:p>
+            <a:pPr algn="l"/>
+            <a:r>
+              <a:rPr sz="1800" b="1">
+                <a:solidFill>
+                  <a:srgbClr val="0E1726"/>
+                </a:solidFill>
+                <a:latin typeface="Arial"/>
+              </a:rPr>
+              <a:t>Submitted by: Soham Y. Surve</a:t>
             </a:r>
           </a:p>
         </p:txBody>
@@ -11020,14 +11053,47 @@
                 </a:solidFill>
                 <a:latin typeface="Arial"/>
               </a:rPr>
-              <a:t>https://github.com/Sohamsurve/PromptShield</a:t>
+              <a:t>https://github.com/Sohamsurve/PromptShield.git</a:t>
+            </a:r>
+          </a:p>
+        </p:txBody>
+      </p:sp>
+      <p:sp>
+        <p:nvSpPr>
+          <p:cNvPr id="11" name="TextBox 10"/>
+          <p:cNvSpPr txBox="1"/>
+          <p:nvPr/>
+        </p:nvSpPr>
+        <p:spPr>
+          <a:xfrm>
+            <a:off x="502920" y="4754880"/>
+            <a:ext cx="9144000" cy="365760"/>
+          </a:xfrm>
+          <a:prstGeom prst="rect">
+            <a:avLst/>
+          </a:prstGeom>
+          <a:noFill/>
+        </p:spPr>
+        <p:txBody>
+          <a:bodyPr wrap="square" anchor="t"/>
+          <a:lstStyle/>
+          <a:p>
+            <a:pPr algn="l"/>
+            <a:r>
+              <a:rPr sz="1800" b="1">
+                <a:solidFill>
+                  <a:srgbClr val="0E1726"/>
+                </a:solidFill>
+                <a:latin typeface="Arial"/>
+              </a:rPr>
+              <a:t>Submitted by: Soham Y. Surve</a:t>
             </a:r>
           </a:p>
         </p:txBody>
       </p:sp>
       <p:pic>
         <p:nvPicPr>
-          <p:cNvPr id="11" name="Picture 10" descr="favicon-512.png"/>
+          <p:cNvPr id="12" name="Picture 11" descr="favicon-512.png"/>
           <p:cNvPicPr>
             <a:picLocks noChangeAspect="1"/>
           </p:cNvPicPr>
@@ -11051,7 +11117,7 @@
       </p:pic>
       <p:sp>
         <p:nvSpPr>
-          <p:cNvPr id="12" name="TextBox 11"/>
+          <p:cNvPr id="13" name="TextBox 12"/>
           <p:cNvSpPr txBox="1"/>
           <p:nvPr/>
         </p:nvSpPr>
@@ -11084,7 +11150,7 @@
       </p:sp>
       <p:sp>
         <p:nvSpPr>
-          <p:cNvPr id="13" name="TextBox 12"/>
+          <p:cNvPr id="14" name="TextBox 13"/>
           <p:cNvSpPr txBox="1"/>
           <p:nvPr/>
         </p:nvSpPr>

</xml_diff>